<commit_message>
Clarify LB3 reflection, future features and invitation to try Spendly
</commit_message>
<xml_diff>
--- a/docs/lb3/Spendly_LB3_Praesentation.pptx
+++ b/docs/lb3/Spendly_LB3_Praesentation.pptx
@@ -2,22 +2,22 @@
 <file path=ppt/presentation.xml><?xml version="1.0" encoding="utf-8"?>
 <p:presentation xmlns:p="http://schemas.openxmlformats.org/presentationml/2006/main">
   <p:sldMasterIdLst>
-    <p:sldMasterId xmlns:r="http://schemas.openxmlformats.org/officeDocument/2006/relationships" id="2147483648" r:id="Re5c093cf7e704b2e"/>
+    <p:sldMasterId xmlns:r="http://schemas.openxmlformats.org/officeDocument/2006/relationships" id="2147483648" r:id="R905f27b78a2547ed"/>
   </p:sldMasterIdLst>
   <p:notesMasterIdLst>
-    <p:notesMasterId xmlns:r="http://schemas.openxmlformats.org/officeDocument/2006/relationships" r:id="Ra37a072923744fd6"/>
+    <p:notesMasterId xmlns:r="http://schemas.openxmlformats.org/officeDocument/2006/relationships" r:id="R9160f916dd514fba"/>
   </p:notesMasterIdLst>
   <p:sldIdLst>
-    <p:sldId xmlns:r="http://schemas.openxmlformats.org/officeDocument/2006/relationships" id="256" r:id="R4471962a1b6a43d0"/>
-    <p:sldId xmlns:r="http://schemas.openxmlformats.org/officeDocument/2006/relationships" id="257" r:id="R81c2ca057d00470f"/>
-    <p:sldId xmlns:r="http://schemas.openxmlformats.org/officeDocument/2006/relationships" id="258" r:id="R3c93456cf0064715"/>
-    <p:sldId xmlns:r="http://schemas.openxmlformats.org/officeDocument/2006/relationships" id="259" r:id="R06c6203881f4436a"/>
-    <p:sldId xmlns:r="http://schemas.openxmlformats.org/officeDocument/2006/relationships" id="260" r:id="Rf90df02d9af1413f"/>
-    <p:sldId xmlns:r="http://schemas.openxmlformats.org/officeDocument/2006/relationships" id="261" r:id="R43e390562c0443a3"/>
-    <p:sldId xmlns:r="http://schemas.openxmlformats.org/officeDocument/2006/relationships" id="262" r:id="R81677bfd054842d2"/>
-    <p:sldId xmlns:r="http://schemas.openxmlformats.org/officeDocument/2006/relationships" id="263" r:id="Re30ae793a26445a4"/>
-    <p:sldId xmlns:r="http://schemas.openxmlformats.org/officeDocument/2006/relationships" id="264" r:id="Rc744d64de1954e20"/>
-    <p:sldId xmlns:r="http://schemas.openxmlformats.org/officeDocument/2006/relationships" id="265" r:id="R8155a8d476ee4083"/>
+    <p:sldId xmlns:r="http://schemas.openxmlformats.org/officeDocument/2006/relationships" id="256" r:id="R18d1135c92d041eb"/>
+    <p:sldId xmlns:r="http://schemas.openxmlformats.org/officeDocument/2006/relationships" id="257" r:id="R3819f78770694f92"/>
+    <p:sldId xmlns:r="http://schemas.openxmlformats.org/officeDocument/2006/relationships" id="258" r:id="R788c10c07a904d6c"/>
+    <p:sldId xmlns:r="http://schemas.openxmlformats.org/officeDocument/2006/relationships" id="259" r:id="R4e523b0372794675"/>
+    <p:sldId xmlns:r="http://schemas.openxmlformats.org/officeDocument/2006/relationships" id="260" r:id="R7746f8875cff4347"/>
+    <p:sldId xmlns:r="http://schemas.openxmlformats.org/officeDocument/2006/relationships" id="261" r:id="R3e6e46c903474093"/>
+    <p:sldId xmlns:r="http://schemas.openxmlformats.org/officeDocument/2006/relationships" id="262" r:id="R697b59f19b974977"/>
+    <p:sldId xmlns:r="http://schemas.openxmlformats.org/officeDocument/2006/relationships" id="263" r:id="R727f35eb8e5b4bde"/>
+    <p:sldId xmlns:r="http://schemas.openxmlformats.org/officeDocument/2006/relationships" id="264" r:id="Rad7334111e1d4793"/>
+    <p:sldId xmlns:r="http://schemas.openxmlformats.org/officeDocument/2006/relationships" id="265" r:id="Rdd9ba39ef87f4f2c"/>
   </p:sldIdLst>
   <p:sldSz cx="12192000" cy="6858000"/>
   <p:notesSz cx="6858000" cy="9144000"/>
@@ -581,7 +581,7 @@
           </a:p>
           <a:p xmlns:a="http://schemas.openxmlformats.org/drawingml/2006/main">
             <a:r>
-              <a:t>Darian: Am Anfang haben wir gefragt, wie ihr entscheidet, was ihr euch heute noch leisten könnt. Spendly macht einen Teil dieser Entscheidung sichtbar: eure erfassten Ausgaben und das restliche Monatsbudget. Wir haben eine funktionierende App gebaut, den Entwurf weiterentwickelt und die wichtigsten Abläufe geprüft. Jetzt interessiert uns euer Blick als mögliche Nutzerinnen und Nutzer. Welche Ausgabe würdet ihr zuerst erfassen? Und was müsste Spendly können, damit ihr es auch nächste Woche noch öffnet?</a:t>
+              <a:t>Darian: Am Anfang haben wir gefragt, wie ihr entscheidet, was ihr euch heute noch leisten könnt. Spendly macht eure erfassten Ausgaben und das restliche Monatsbudget sichtbar. Wir haben aus dem Entwurf eine funktionierende App gemacht und die wichtigsten Abläufe geprüft. Jetzt seid ihr dran: Wollt ihr Spendly ausprobieren? Welche Funktion würdet ihr euch für euren Alltag wünschen? Eure Ideen würden uns helfen, die nächste Version gezielt zu verbessern.</a:t>
             </a:r>
           </a:p>
           <a:p xmlns:a="http://schemas.openxmlformats.org/drawingml/2006/main">
@@ -591,7 +591,7 @@
           </a:p>
           <a:p xmlns:a="http://schemas.openxmlformats.org/drawingml/2006/main">
             <a:r>
-              <a:t>[Eine kurze Antwort aufnehmen und in die Fragerunde überleiten.]</a:t>
+              <a:t>[Die Einladung kurz wirken lassen und in die Fragerunde überleiten.]</a:t>
             </a:r>
           </a:p>
           <a:p xmlns:a="http://schemas.openxmlformats.org/drawingml/2006/main">
@@ -1651,7 +1651,7 @@
           </a:p>
           <a:p xmlns:a="http://schemas.openxmlformats.org/drawingml/2006/main">
             <a:r>
-              <a:t>Darian: Der nächste Schritt wäre eine kleine Alltagsprobe: fünf Lernende oder Studierende nutzen Spendly eine Woche. Das ist unser Vorschlag, kein bereits durchgeführter Pilot. Wir würden beobachten, wie schnell eine Erfassung gelingt, ob die Tagesorientierung verständlich ist und ob die Personen freiwillig wiederkommen. Erst danach lässt sich entscheiden, welche Erweiterung hilfreich ist und ob ein Geschäftsmodell Sinn ergibt. Vor einem Launch gehören auch der echte iPhone-Test, Android und Screenreader dazu. Aus der Entwicklung nehmen wir mit, Fehlerfälle früher zu planen. Ein altes Monatsbudget darf sich beim Ändern des neuen Monats nicht verschieben. Ein Neustart darf keine Sperrfrist zurücksetzen. Diese Erfahrungen würden wir im nächsten Durchgang schon beim Entwurf berücksichtigen.</a:t>
+              <a:t>Darian: Unser Rückblick ist konkret: Ein Monatsbudget braucht eine feste Zuordnung zum Monat. Sonst verändert ein neuer Wert auch die Vergangenheit. Auch die Rückgängig-Frist und die PIN-Sperre müssen einen Neustart überstehen. Das waren Herausforderungen, für die wir dauerhafte Zustände speichern mussten. Beim nächsten Projekt würden wir solche Fehlerfälle früher im Entwurf planen. Im Ausblick könnten wir Spendly um einen CSV-Export für Ausgaben oder Statistiken nach Kategorien erweitern. Diese Funktionen sind Ideen für spätere Versionen und noch nicht umgesetzt. Zuerst würden wir mit Lernenden prüfen, ob sie die Tagesorientierung verstehen und welche Erweiterung ihnen hilft. Die offenen Geräte- und Barrierefreiheitstests bleiben ebenfalls wichtig.</a:t>
             </a:r>
           </a:p>
           <a:p xmlns:a="http://schemas.openxmlformats.org/drawingml/2006/main">
@@ -1691,12 +1691,17 @@
           </a:p>
           <a:p xmlns:a="http://schemas.openxmlformats.org/drawingml/2006/main">
             <a:r>
+              <a:t>Datei: storage/expenses.js</a:t>
+            </a:r>
+          </a:p>
+          <a:p xmlns:a="http://schemas.openxmlformats.org/drawingml/2006/main">
+            <a:r>
               <a:t>Datei: screens/NewExpenseScreen.js</a:t>
             </a:r>
           </a:p>
           <a:p xmlns:a="http://schemas.openxmlformats.org/drawingml/2006/main">
             <a:r>
-              <a:t>Die fünf Personen und eine Woche sind ein vorgeschlagener Nutzertest. Keine bestätigten Nutzer, Umsätze oder Finanzierungsrunde.</a:t>
+              <a:t>CSV-Export und Kategorie-Statistiken sind mögliche Erweiterungen, keine vorhandenen Funktionen. Kein Nutzertest ist als durchgeführt behauptet.</a:t>
             </a:r>
           </a:p>
         </p:txBody>
@@ -1764,7 +1769,7 @@
   </p:cSld>
   <p:clrMap bg1="lt1" tx1="dk1" bg2="lt2" tx2="dk2" accent1="accent1" accent2="accent2" accent3="accent3" accent4="accent4" accent5="accent5" accent6="accent6" hlink="hlink" folHlink="folHlink"/>
   <p:sldLayoutIdLst>
-    <p:sldLayoutId xmlns:r="http://schemas.openxmlformats.org/officeDocument/2006/relationships" id="2147483649" r:id="Re0ffd5f4382140cf"/>
+    <p:sldLayoutId xmlns:r="http://schemas.openxmlformats.org/officeDocument/2006/relationships" id="2147483649" r:id="R7d5d39f4492243d5"/>
   </p:sldLayoutIdLst>
   <p:txStyles>
     <p:titleStyle>
@@ -2315,7 +2320,7 @@
           <p:cNvPr id="5" name="">
             <a:extLst xmlns:a="http://schemas.openxmlformats.org/drawingml/2006/main">
               <a:ext uri="{FF2B5EF4-FFF2-40B4-BE49-F238E27FC236}">
-                <a16:creationId xmlns:a16="http://schemas.microsoft.com/office/drawing/2014/main" id="{CE6DC4BD-200B-4336-8706-1A8D3EE7F618}"/>
+                <a16:creationId xmlns:a16="http://schemas.microsoft.com/office/drawing/2014/main" id="{DF3A51FC-3D1F-41DA-A75F-1260A7DD0444}"/>
               </a:ext>
             </a:extLst>
           </p:cNvPr>
@@ -2372,7 +2377,7 @@
           <p:cNvPr id="2" name="">
             <a:extLst xmlns:a="http://schemas.openxmlformats.org/drawingml/2006/main">
               <a:ext uri="{FF2B5EF4-FFF2-40B4-BE49-F238E27FC236}">
-                <a16:creationId xmlns:a16="http://schemas.microsoft.com/office/drawing/2014/main" id="{AAA9DDFC-1119-402F-BE0B-8F77200840BB}"/>
+                <a16:creationId xmlns:a16="http://schemas.microsoft.com/office/drawing/2014/main" id="{EE5BBF72-7284-415D-AE5F-0D6D24405CB0}"/>
               </a:ext>
             </a:extLst>
           </p:cNvPr>
@@ -2475,7 +2480,7 @@
           <p:cNvPr id="3" name="">
             <a:extLst xmlns:a="http://schemas.openxmlformats.org/drawingml/2006/main">
               <a:ext uri="{FF2B5EF4-FFF2-40B4-BE49-F238E27FC236}">
-                <a16:creationId xmlns:a16="http://schemas.microsoft.com/office/drawing/2014/main" id="{25CC1988-9CBB-4818-B922-168AF33DA6BB}"/>
+                <a16:creationId xmlns:a16="http://schemas.microsoft.com/office/drawing/2014/main" id="{2E53050E-AE18-4178-BE98-3478382D158D}"/>
               </a:ext>
             </a:extLst>
           </p:cNvPr>
@@ -2532,7 +2537,7 @@
           <p:cNvPr id="4" name="">
             <a:extLst xmlns:a="http://schemas.openxmlformats.org/drawingml/2006/main">
               <a:ext uri="{FF2B5EF4-FFF2-40B4-BE49-F238E27FC236}">
-                <a16:creationId xmlns:a16="http://schemas.microsoft.com/office/drawing/2014/main" id="{D73F961F-B116-4AB2-BC0B-C77F07D486B7}"/>
+                <a16:creationId xmlns:a16="http://schemas.microsoft.com/office/drawing/2014/main" id="{C2882339-009A-49AC-8975-204B55A229A8}"/>
               </a:ext>
             </a:extLst>
           </p:cNvPr>
@@ -2587,7 +2592,7 @@
     </p:spTree>
     <p:extLst>
       <p:ext uri="{BB962C8B-B14F-4D97-AF65-F5344CB8AC3E}">
-        <p14:creationId xmlns:p14="http://schemas.microsoft.com/office/powerpoint/2010/main" val="1363150488"/>
+        <p14:creationId xmlns:p14="http://schemas.microsoft.com/office/powerpoint/2010/main" val="635395001"/>
       </p:ext>
     </p:extLst>
   </p:cSld>
@@ -2618,7 +2623,7 @@
           <p:cNvPr id="6" name="">
             <a:extLst xmlns:a="http://schemas.openxmlformats.org/drawingml/2006/main">
               <a:ext uri="{FF2B5EF4-FFF2-40B4-BE49-F238E27FC236}">
-                <a16:creationId xmlns:a16="http://schemas.microsoft.com/office/drawing/2014/main" id="{BA6CDA79-18A7-4EDB-978A-27F44232B2A9}"/>
+                <a16:creationId xmlns:a16="http://schemas.microsoft.com/office/drawing/2014/main" id="{D95ADF76-9522-4A6C-BADD-9CC95660778F}"/>
               </a:ext>
             </a:extLst>
           </p:cNvPr>
@@ -2675,7 +2680,7 @@
           <p:cNvPr id="2" name="">
             <a:extLst xmlns:a="http://schemas.openxmlformats.org/drawingml/2006/main">
               <a:ext uri="{FF2B5EF4-FFF2-40B4-BE49-F238E27FC236}">
-                <a16:creationId xmlns:a16="http://schemas.microsoft.com/office/drawing/2014/main" id="{06D1F899-5E30-4E77-84C7-0D2F8C426A8D}"/>
+                <a16:creationId xmlns:a16="http://schemas.microsoft.com/office/drawing/2014/main" id="{8FAE1233-6347-4535-95BE-4E65492C23AB}"/>
               </a:ext>
             </a:extLst>
           </p:cNvPr>
@@ -2732,7 +2737,7 @@
           <p:cNvPr id="3" name="">
             <a:extLst xmlns:a="http://schemas.openxmlformats.org/drawingml/2006/main">
               <a:ext uri="{FF2B5EF4-FFF2-40B4-BE49-F238E27FC236}">
-                <a16:creationId xmlns:a16="http://schemas.microsoft.com/office/drawing/2014/main" id="{E6B79EE1-6EBE-4831-BF50-BAF411DA366A}"/>
+                <a16:creationId xmlns:a16="http://schemas.microsoft.com/office/drawing/2014/main" id="{792F2C18-9124-46A0-9E2D-4D0BB1DF9786}"/>
               </a:ext>
             </a:extLst>
           </p:cNvPr>
@@ -2779,7 +2784,7 @@
                 <a:ea typeface="Newsreader"/>
                 <a:cs typeface="Newsreader"/>
               </a:rPr>
-              <a:t>Was kannst du dir</a:t>
+              <a:t>Wollt ihr Spendly</a:t>
             </a:r>
           </a:p>
           <a:p xmlns:a="http://schemas.openxmlformats.org/drawingml/2006/main">
@@ -2802,7 +2807,7 @@
                 <a:ea typeface="Newsreader"/>
                 <a:cs typeface="Newsreader"/>
               </a:rPr>
-              <a:t>heute noch leisten?</a:t>
+              <a:t>ausprobieren?</a:t>
             </a:r>
           </a:p>
         </p:txBody>
@@ -2812,7 +2817,7 @@
           <p:cNvPr id="4" name="">
             <a:extLst xmlns:a="http://schemas.openxmlformats.org/drawingml/2006/main">
               <a:ext uri="{FF2B5EF4-FFF2-40B4-BE49-F238E27FC236}">
-                <a16:creationId xmlns:a16="http://schemas.microsoft.com/office/drawing/2014/main" id="{1F4AAE30-6F1B-4893-A608-54F9A9073B71}"/>
+                <a16:creationId xmlns:a16="http://schemas.microsoft.com/office/drawing/2014/main" id="{ADA78005-BD70-4871-99CC-E5AAE7708A0B}"/>
               </a:ext>
             </a:extLst>
           </p:cNvPr>
@@ -2869,7 +2874,7 @@
           <p:cNvPr id="5" name="">
             <a:extLst xmlns:a="http://schemas.openxmlformats.org/drawingml/2006/main">
               <a:ext uri="{FF2B5EF4-FFF2-40B4-BE49-F238E27FC236}">
-                <a16:creationId xmlns:a16="http://schemas.microsoft.com/office/drawing/2014/main" id="{42228BFC-4F67-4DF2-B4A1-AA5EE6DE4743}"/>
+                <a16:creationId xmlns:a16="http://schemas.microsoft.com/office/drawing/2014/main" id="{3852645F-FAA0-40B4-B2BD-1DCE54E40C4B}"/>
               </a:ext>
             </a:extLst>
           </p:cNvPr>
@@ -2881,7 +2886,7 @@
         <p:spPr>
           <a:xfrm xmlns:a="http://schemas.openxmlformats.org/drawingml/2006/main">
             <a:off x="685800" y="5676900"/>
-            <a:ext cx="9763125" cy="409575"/>
+            <a:ext cx="10639425" cy="409575"/>
           </a:xfrm>
           <a:prstGeom xmlns:a="http://schemas.openxmlformats.org/drawingml/2006/main" prst="rect">
             <a:avLst/>
@@ -2916,7 +2921,7 @@
                 <a:ea typeface="Inter"/>
                 <a:cs typeface="Inter"/>
               </a:rPr>
-              <a:t>Wie würdet ihr Spendly im Alltag nutzen?</a:t>
+              <a:t>Euer Feedback hilft uns bei der nächsten Version.</a:t>
             </a:r>
           </a:p>
         </p:txBody>
@@ -2924,7 +2929,7 @@
     </p:spTree>
     <p:extLst>
       <p:ext uri="{BB962C8B-B14F-4D97-AF65-F5344CB8AC3E}">
-        <p14:creationId xmlns:p14="http://schemas.microsoft.com/office/powerpoint/2010/main" val="527983319"/>
+        <p14:creationId xmlns:p14="http://schemas.microsoft.com/office/powerpoint/2010/main" val="2100802997"/>
       </p:ext>
     </p:extLst>
   </p:cSld>
@@ -2955,7 +2960,7 @@
           <p:cNvPr id="18" name="">
             <a:extLst xmlns:a="http://schemas.openxmlformats.org/drawingml/2006/main">
               <a:ext uri="{FF2B5EF4-FFF2-40B4-BE49-F238E27FC236}">
-                <a16:creationId xmlns:a16="http://schemas.microsoft.com/office/drawing/2014/main" id="{AE1242BA-E8F0-4A6A-9D69-35FD128A9DCB}"/>
+                <a16:creationId xmlns:a16="http://schemas.microsoft.com/office/drawing/2014/main" id="{6C0F7888-F29E-4C58-A84F-BB51F3B37752}"/>
               </a:ext>
             </a:extLst>
           </p:cNvPr>
@@ -3012,7 +3017,7 @@
           <p:cNvPr id="2" name="">
             <a:extLst xmlns:a="http://schemas.openxmlformats.org/drawingml/2006/main">
               <a:ext uri="{FF2B5EF4-FFF2-40B4-BE49-F238E27FC236}">
-                <a16:creationId xmlns:a16="http://schemas.microsoft.com/office/drawing/2014/main" id="{0037DD46-AF23-4563-B80D-5AB63F24B9E4}"/>
+                <a16:creationId xmlns:a16="http://schemas.microsoft.com/office/drawing/2014/main" id="{0EF394B1-3DF4-460A-B2F4-346C4CD2D43C}"/>
               </a:ext>
             </a:extLst>
           </p:cNvPr>
@@ -3069,7 +3074,7 @@
           <p:cNvPr id="3" name="">
             <a:extLst xmlns:a="http://schemas.openxmlformats.org/drawingml/2006/main">
               <a:ext uri="{FF2B5EF4-FFF2-40B4-BE49-F238E27FC236}">
-                <a16:creationId xmlns:a16="http://schemas.microsoft.com/office/drawing/2014/main" id="{19822F18-16FC-4F23-A6CF-A885F7198A07}"/>
+                <a16:creationId xmlns:a16="http://schemas.microsoft.com/office/drawing/2014/main" id="{B919C897-AE9C-46A2-B103-2CD78F9E92F8}"/>
               </a:ext>
             </a:extLst>
           </p:cNvPr>
@@ -3126,7 +3131,7 @@
           <p:cNvPr id="4" name="">
             <a:extLst xmlns:a="http://schemas.openxmlformats.org/drawingml/2006/main">
               <a:ext uri="{FF2B5EF4-FFF2-40B4-BE49-F238E27FC236}">
-                <a16:creationId xmlns:a16="http://schemas.microsoft.com/office/drawing/2014/main" id="{5E1DFACB-B485-4ADD-B55D-1A36442B8EFB}"/>
+                <a16:creationId xmlns:a16="http://schemas.microsoft.com/office/drawing/2014/main" id="{B9FCC955-71CB-428C-86D6-6DEA58BE8210}"/>
               </a:ext>
             </a:extLst>
           </p:cNvPr>
@@ -3206,7 +3211,7 @@
           <p:cNvPr id="5" name="">
             <a:extLst xmlns:a="http://schemas.openxmlformats.org/drawingml/2006/main">
               <a:ext uri="{FF2B5EF4-FFF2-40B4-BE49-F238E27FC236}">
-                <a16:creationId xmlns:a16="http://schemas.microsoft.com/office/drawing/2014/main" id="{FF6E1AAB-BE33-4765-A4FB-6C080E639471}"/>
+                <a16:creationId xmlns:a16="http://schemas.microsoft.com/office/drawing/2014/main" id="{83D50D7B-7C4D-481A-A0B2-04F8767A33D1}"/>
               </a:ext>
             </a:extLst>
           </p:cNvPr>
@@ -3286,7 +3291,7 @@
           <p:cNvPr id="6" name="">
             <a:extLst xmlns:a="http://schemas.openxmlformats.org/drawingml/2006/main">
               <a:ext uri="{FF2B5EF4-FFF2-40B4-BE49-F238E27FC236}">
-                <a16:creationId xmlns:a16="http://schemas.microsoft.com/office/drawing/2014/main" id="{55008F34-A9A2-4D88-869E-9AB516B3770A}"/>
+                <a16:creationId xmlns:a16="http://schemas.microsoft.com/office/drawing/2014/main" id="{F3C9C272-AC0F-49C5-B4C6-64ACD5F2ABAA}"/>
               </a:ext>
             </a:extLst>
           </p:cNvPr>
@@ -3343,7 +3348,7 @@
           <p:cNvPr id="7" name="">
             <a:extLst xmlns:a="http://schemas.openxmlformats.org/drawingml/2006/main">
               <a:ext uri="{FF2B5EF4-FFF2-40B4-BE49-F238E27FC236}">
-                <a16:creationId xmlns:a16="http://schemas.microsoft.com/office/drawing/2014/main" id="{2AF23667-D615-4AAD-A71B-9715DE5A1403}"/>
+                <a16:creationId xmlns:a16="http://schemas.microsoft.com/office/drawing/2014/main" id="{5DCCB865-5041-41EA-B7DF-08BD22754B4B}"/>
               </a:ext>
             </a:extLst>
           </p:cNvPr>
@@ -3400,7 +3405,7 @@
           <p:cNvPr id="8" name="">
             <a:extLst xmlns:a="http://schemas.openxmlformats.org/drawingml/2006/main">
               <a:ext uri="{FF2B5EF4-FFF2-40B4-BE49-F238E27FC236}">
-                <a16:creationId xmlns:a16="http://schemas.microsoft.com/office/drawing/2014/main" id="{B758581B-26DF-458A-9381-B71E5EFB2D94}"/>
+                <a16:creationId xmlns:a16="http://schemas.microsoft.com/office/drawing/2014/main" id="{560815B4-A802-4289-81EE-B61D830A7DDA}"/>
               </a:ext>
             </a:extLst>
           </p:cNvPr>
@@ -3457,7 +3462,7 @@
           <p:cNvPr id="9" name="">
             <a:extLst xmlns:a="http://schemas.openxmlformats.org/drawingml/2006/main">
               <a:ext uri="{FF2B5EF4-FFF2-40B4-BE49-F238E27FC236}">
-                <a16:creationId xmlns:a16="http://schemas.microsoft.com/office/drawing/2014/main" id="{D3E67FBC-2152-42AD-88C1-F9FA3EA8332D}"/>
+                <a16:creationId xmlns:a16="http://schemas.microsoft.com/office/drawing/2014/main" id="{7ADDFBC4-A2D2-4282-9EA7-9429E5C48490}"/>
               </a:ext>
             </a:extLst>
           </p:cNvPr>
@@ -3487,7 +3492,7 @@
           <p:cNvPr id="10" name="">
             <a:extLst xmlns:a="http://schemas.openxmlformats.org/drawingml/2006/main">
               <a:ext uri="{FF2B5EF4-FFF2-40B4-BE49-F238E27FC236}">
-                <a16:creationId xmlns:a16="http://schemas.microsoft.com/office/drawing/2014/main" id="{6CFBD7A3-C2B3-45AC-BC34-224BDD519C2D}"/>
+                <a16:creationId xmlns:a16="http://schemas.microsoft.com/office/drawing/2014/main" id="{457F66BF-DEDF-42A2-80C3-CF576D29269E}"/>
               </a:ext>
             </a:extLst>
           </p:cNvPr>
@@ -3544,7 +3549,7 @@
           <p:cNvPr id="11" name="">
             <a:extLst xmlns:a="http://schemas.openxmlformats.org/drawingml/2006/main">
               <a:ext uri="{FF2B5EF4-FFF2-40B4-BE49-F238E27FC236}">
-                <a16:creationId xmlns:a16="http://schemas.microsoft.com/office/drawing/2014/main" id="{61E51398-A0D6-4389-8D09-CE75394994BF}"/>
+                <a16:creationId xmlns:a16="http://schemas.microsoft.com/office/drawing/2014/main" id="{6C512A3B-5C91-4E89-89C1-CF5839E7A0B8}"/>
               </a:ext>
             </a:extLst>
           </p:cNvPr>
@@ -3601,7 +3606,7 @@
           <p:cNvPr id="12" name="">
             <a:extLst xmlns:a="http://schemas.openxmlformats.org/drawingml/2006/main">
               <a:ext uri="{FF2B5EF4-FFF2-40B4-BE49-F238E27FC236}">
-                <a16:creationId xmlns:a16="http://schemas.microsoft.com/office/drawing/2014/main" id="{20EC5BCF-7A67-48A5-81C9-3ECE251EA8EC}"/>
+                <a16:creationId xmlns:a16="http://schemas.microsoft.com/office/drawing/2014/main" id="{EE7A38C9-64AD-4989-ACCB-9C8F9F4A68C9}"/>
               </a:ext>
             </a:extLst>
           </p:cNvPr>
@@ -3631,7 +3636,7 @@
           <p:cNvPr id="13" name="">
             <a:extLst xmlns:a="http://schemas.openxmlformats.org/drawingml/2006/main">
               <a:ext uri="{FF2B5EF4-FFF2-40B4-BE49-F238E27FC236}">
-                <a16:creationId xmlns:a16="http://schemas.microsoft.com/office/drawing/2014/main" id="{C84DD131-01C7-4EF8-B053-93AE31762F2C}"/>
+                <a16:creationId xmlns:a16="http://schemas.microsoft.com/office/drawing/2014/main" id="{C0F87CED-1EF4-43CC-8696-00957CA05603}"/>
               </a:ext>
             </a:extLst>
           </p:cNvPr>
@@ -3688,7 +3693,7 @@
           <p:cNvPr id="14" name="">
             <a:extLst xmlns:a="http://schemas.openxmlformats.org/drawingml/2006/main">
               <a:ext uri="{FF2B5EF4-FFF2-40B4-BE49-F238E27FC236}">
-                <a16:creationId xmlns:a16="http://schemas.microsoft.com/office/drawing/2014/main" id="{CC263790-A3F9-45C1-AA32-AA555B65DBDC}"/>
+                <a16:creationId xmlns:a16="http://schemas.microsoft.com/office/drawing/2014/main" id="{25288B9D-5C00-4047-88A6-4335E22A4C61}"/>
               </a:ext>
             </a:extLst>
           </p:cNvPr>
@@ -3745,7 +3750,7 @@
           <p:cNvPr id="15" name="">
             <a:extLst xmlns:a="http://schemas.openxmlformats.org/drawingml/2006/main">
               <a:ext uri="{FF2B5EF4-FFF2-40B4-BE49-F238E27FC236}">
-                <a16:creationId xmlns:a16="http://schemas.microsoft.com/office/drawing/2014/main" id="{218E6417-7731-4BBC-B21C-8531163718F1}"/>
+                <a16:creationId xmlns:a16="http://schemas.microsoft.com/office/drawing/2014/main" id="{70BDA0D1-0CB9-4DFC-99BD-30B8C30DBA19}"/>
               </a:ext>
             </a:extLst>
           </p:cNvPr>
@@ -3775,7 +3780,7 @@
           <p:cNvPr id="16" name="">
             <a:extLst xmlns:a="http://schemas.openxmlformats.org/drawingml/2006/main">
               <a:ext uri="{FF2B5EF4-FFF2-40B4-BE49-F238E27FC236}">
-                <a16:creationId xmlns:a16="http://schemas.microsoft.com/office/drawing/2014/main" id="{E6AAA21B-AA6D-43E4-8E09-01924FC3ACB4}"/>
+                <a16:creationId xmlns:a16="http://schemas.microsoft.com/office/drawing/2014/main" id="{29753486-5213-445A-BA03-F85892CF8DF1}"/>
               </a:ext>
             </a:extLst>
           </p:cNvPr>
@@ -3832,7 +3837,7 @@
           <p:cNvPr id="17" name="">
             <a:extLst xmlns:a="http://schemas.openxmlformats.org/drawingml/2006/main">
               <a:ext uri="{FF2B5EF4-FFF2-40B4-BE49-F238E27FC236}">
-                <a16:creationId xmlns:a16="http://schemas.microsoft.com/office/drawing/2014/main" id="{C8F36159-58AD-4338-BC57-6A994E9A4ADF}"/>
+                <a16:creationId xmlns:a16="http://schemas.microsoft.com/office/drawing/2014/main" id="{325FDE3B-8062-4D01-A8D6-D3F6BC3020FB}"/>
               </a:ext>
             </a:extLst>
           </p:cNvPr>
@@ -3887,7 +3892,7 @@
     </p:spTree>
     <p:extLst>
       <p:ext uri="{BB962C8B-B14F-4D97-AF65-F5344CB8AC3E}">
-        <p14:creationId xmlns:p14="http://schemas.microsoft.com/office/powerpoint/2010/main" val="596746945"/>
+        <p14:creationId xmlns:p14="http://schemas.microsoft.com/office/powerpoint/2010/main" val="321554564"/>
       </p:ext>
     </p:extLst>
   </p:cSld>
@@ -3918,7 +3923,7 @@
           <p:cNvPr id="6" name="">
             <a:extLst xmlns:a="http://schemas.openxmlformats.org/drawingml/2006/main">
               <a:ext uri="{FF2B5EF4-FFF2-40B4-BE49-F238E27FC236}">
-                <a16:creationId xmlns:a16="http://schemas.microsoft.com/office/drawing/2014/main" id="{CD8318F3-B2DA-4292-A8FC-CC8ACCFBC529}"/>
+                <a16:creationId xmlns:a16="http://schemas.microsoft.com/office/drawing/2014/main" id="{EDB886B4-82BE-4C72-A3ED-EC03D6421526}"/>
               </a:ext>
             </a:extLst>
           </p:cNvPr>
@@ -3975,7 +3980,7 @@
           <p:cNvPr id="2" name="">
             <a:extLst xmlns:a="http://schemas.openxmlformats.org/drawingml/2006/main">
               <a:ext uri="{FF2B5EF4-FFF2-40B4-BE49-F238E27FC236}">
-                <a16:creationId xmlns:a16="http://schemas.microsoft.com/office/drawing/2014/main" id="{5E0DC381-CD30-448A-87C7-52B841FF608E}"/>
+                <a16:creationId xmlns:a16="http://schemas.microsoft.com/office/drawing/2014/main" id="{131EE3C7-47B2-430E-99C1-6E15C60D081C}"/>
               </a:ext>
             </a:extLst>
           </p:cNvPr>
@@ -4032,7 +4037,7 @@
           <p:cNvPr id="3" name="">
             <a:extLst xmlns:a="http://schemas.openxmlformats.org/drawingml/2006/main">
               <a:ext uri="{FF2B5EF4-FFF2-40B4-BE49-F238E27FC236}">
-                <a16:creationId xmlns:a16="http://schemas.microsoft.com/office/drawing/2014/main" id="{DD141019-32B9-43E8-AD8F-CA8F87DE369D}"/>
+                <a16:creationId xmlns:a16="http://schemas.microsoft.com/office/drawing/2014/main" id="{71B52AD9-9DBB-4CF0-96DE-45D26BB5D422}"/>
               </a:ext>
             </a:extLst>
           </p:cNvPr>
@@ -4112,7 +4117,7 @@
           <p:cNvPr id="4" name="">
             <a:extLst xmlns:a="http://schemas.openxmlformats.org/drawingml/2006/main">
               <a:ext uri="{FF2B5EF4-FFF2-40B4-BE49-F238E27FC236}">
-                <a16:creationId xmlns:a16="http://schemas.microsoft.com/office/drawing/2014/main" id="{12121166-973F-4EBD-84AC-19DEE884CBE4}"/>
+                <a16:creationId xmlns:a16="http://schemas.microsoft.com/office/drawing/2014/main" id="{E1ABB24C-E9CC-4800-B0FA-717FCA770C4B}"/>
               </a:ext>
             </a:extLst>
           </p:cNvPr>
@@ -4196,7 +4201,7 @@
           <p:nvPr/>
         </p:nvPicPr>
         <p:blipFill>
-          <a:blip xmlns:r="http://schemas.openxmlformats.org/officeDocument/2006/relationships" xmlns:a="http://schemas.openxmlformats.org/drawingml/2006/main" r:embed="R718d75720fe94779"/>
+          <a:blip xmlns:r="http://schemas.openxmlformats.org/officeDocument/2006/relationships" xmlns:a="http://schemas.openxmlformats.org/drawingml/2006/main" r:embed="Re3aaa20c8a2a4e9e"/>
           <a:stretch xmlns:a="http://schemas.openxmlformats.org/drawingml/2006/main"/>
         </p:blipFill>
         <p:spPr>
@@ -4212,7 +4217,7 @@
     </p:spTree>
     <p:extLst>
       <p:ext uri="{BB962C8B-B14F-4D97-AF65-F5344CB8AC3E}">
-        <p14:creationId xmlns:p14="http://schemas.microsoft.com/office/powerpoint/2010/main" val="742497724"/>
+        <p14:creationId xmlns:p14="http://schemas.microsoft.com/office/powerpoint/2010/main" val="1908114061"/>
       </p:ext>
     </p:extLst>
   </p:cSld>
@@ -4243,7 +4248,7 @@
           <p:cNvPr id="13" name="">
             <a:extLst xmlns:a="http://schemas.openxmlformats.org/drawingml/2006/main">
               <a:ext uri="{FF2B5EF4-FFF2-40B4-BE49-F238E27FC236}">
-                <a16:creationId xmlns:a16="http://schemas.microsoft.com/office/drawing/2014/main" id="{D86CFC74-AD06-45C8-8CC4-7B3057A1B7EB}"/>
+                <a16:creationId xmlns:a16="http://schemas.microsoft.com/office/drawing/2014/main" id="{F8F4E52C-9CF9-4C29-8D36-D3ABBEF08CFB}"/>
               </a:ext>
             </a:extLst>
           </p:cNvPr>
@@ -4300,7 +4305,7 @@
           <p:cNvPr id="2" name="">
             <a:extLst xmlns:a="http://schemas.openxmlformats.org/drawingml/2006/main">
               <a:ext uri="{FF2B5EF4-FFF2-40B4-BE49-F238E27FC236}">
-                <a16:creationId xmlns:a16="http://schemas.microsoft.com/office/drawing/2014/main" id="{FFB28E15-0CC1-4210-8EEF-1D779A586259}"/>
+                <a16:creationId xmlns:a16="http://schemas.microsoft.com/office/drawing/2014/main" id="{6140DD78-48BF-4EDC-93CC-1570BEAEEDA4}"/>
               </a:ext>
             </a:extLst>
           </p:cNvPr>
@@ -4357,7 +4362,7 @@
           <p:cNvPr id="3" name="">
             <a:extLst xmlns:a="http://schemas.openxmlformats.org/drawingml/2006/main">
               <a:ext uri="{FF2B5EF4-FFF2-40B4-BE49-F238E27FC236}">
-                <a16:creationId xmlns:a16="http://schemas.microsoft.com/office/drawing/2014/main" id="{C10D774C-ED74-460F-A803-FFF49F245C33}"/>
+                <a16:creationId xmlns:a16="http://schemas.microsoft.com/office/drawing/2014/main" id="{67E1032C-AF94-408D-B33C-BF95AE01E560}"/>
               </a:ext>
             </a:extLst>
           </p:cNvPr>
@@ -4414,7 +4419,7 @@
           <p:cNvPr id="4" name="">
             <a:extLst xmlns:a="http://schemas.openxmlformats.org/drawingml/2006/main">
               <a:ext uri="{FF2B5EF4-FFF2-40B4-BE49-F238E27FC236}">
-                <a16:creationId xmlns:a16="http://schemas.microsoft.com/office/drawing/2014/main" id="{8C5FAB98-6F66-4C8D-8FDF-2101ED6D3B68}"/>
+                <a16:creationId xmlns:a16="http://schemas.microsoft.com/office/drawing/2014/main" id="{73483E75-818D-4E41-A03E-2B25AB7FD293}"/>
               </a:ext>
             </a:extLst>
           </p:cNvPr>
@@ -4471,7 +4476,7 @@
           <p:cNvPr id="5" name="">
             <a:extLst xmlns:a="http://schemas.openxmlformats.org/drawingml/2006/main">
               <a:ext uri="{FF2B5EF4-FFF2-40B4-BE49-F238E27FC236}">
-                <a16:creationId xmlns:a16="http://schemas.microsoft.com/office/drawing/2014/main" id="{16DA37FE-50AC-47AA-B9FA-8BC94E6C6B11}"/>
+                <a16:creationId xmlns:a16="http://schemas.microsoft.com/office/drawing/2014/main" id="{97A8EE6C-EBE6-4F9A-93B9-DED340130183}"/>
               </a:ext>
             </a:extLst>
           </p:cNvPr>
@@ -4528,7 +4533,7 @@
           <p:cNvPr id="6" name="">
             <a:extLst xmlns:a="http://schemas.openxmlformats.org/drawingml/2006/main">
               <a:ext uri="{FF2B5EF4-FFF2-40B4-BE49-F238E27FC236}">
-                <a16:creationId xmlns:a16="http://schemas.microsoft.com/office/drawing/2014/main" id="{FF5C0B8A-ADE5-49BF-97D5-6A1AF8F0928C}"/>
+                <a16:creationId xmlns:a16="http://schemas.microsoft.com/office/drawing/2014/main" id="{BE649C59-8F46-4672-A57B-ACCCA1A841DA}"/>
               </a:ext>
             </a:extLst>
           </p:cNvPr>
@@ -4585,7 +4590,7 @@
           <p:cNvPr id="7" name="">
             <a:extLst xmlns:a="http://schemas.openxmlformats.org/drawingml/2006/main">
               <a:ext uri="{FF2B5EF4-FFF2-40B4-BE49-F238E27FC236}">
-                <a16:creationId xmlns:a16="http://schemas.microsoft.com/office/drawing/2014/main" id="{75E524BD-60C0-4F27-AEE0-F883BC60A1DA}"/>
+                <a16:creationId xmlns:a16="http://schemas.microsoft.com/office/drawing/2014/main" id="{5A567AFF-2B3E-42D6-BD28-EACA0747825C}"/>
               </a:ext>
             </a:extLst>
           </p:cNvPr>
@@ -4642,7 +4647,7 @@
           <p:cNvPr id="8" name="">
             <a:extLst xmlns:a="http://schemas.openxmlformats.org/drawingml/2006/main">
               <a:ext uri="{FF2B5EF4-FFF2-40B4-BE49-F238E27FC236}">
-                <a16:creationId xmlns:a16="http://schemas.microsoft.com/office/drawing/2014/main" id="{A598BD24-89D5-477D-A39A-BBEF9138498C}"/>
+                <a16:creationId xmlns:a16="http://schemas.microsoft.com/office/drawing/2014/main" id="{F41F2844-5F6F-4D12-9FE8-EA821222F4E5}"/>
               </a:ext>
             </a:extLst>
           </p:cNvPr>
@@ -4699,7 +4704,7 @@
           <p:cNvPr id="9" name="">
             <a:extLst xmlns:a="http://schemas.openxmlformats.org/drawingml/2006/main">
               <a:ext uri="{FF2B5EF4-FFF2-40B4-BE49-F238E27FC236}">
-                <a16:creationId xmlns:a16="http://schemas.microsoft.com/office/drawing/2014/main" id="{2FA564D6-5725-4EFD-82FC-4A7ABECEC1B2}"/>
+                <a16:creationId xmlns:a16="http://schemas.microsoft.com/office/drawing/2014/main" id="{3815FF2B-31EB-46E7-BCA5-9AC13DCB6897}"/>
               </a:ext>
             </a:extLst>
           </p:cNvPr>
@@ -4756,7 +4761,7 @@
           <p:cNvPr id="10" name="">
             <a:extLst xmlns:a="http://schemas.openxmlformats.org/drawingml/2006/main">
               <a:ext uri="{FF2B5EF4-FFF2-40B4-BE49-F238E27FC236}">
-                <a16:creationId xmlns:a16="http://schemas.microsoft.com/office/drawing/2014/main" id="{65665EEB-CD49-4405-9331-9CBF852B70B8}"/>
+                <a16:creationId xmlns:a16="http://schemas.microsoft.com/office/drawing/2014/main" id="{F6C67F9A-E203-4227-8209-FE27C86848EF}"/>
               </a:ext>
             </a:extLst>
           </p:cNvPr>
@@ -4813,7 +4818,7 @@
           <p:cNvPr id="11" name="">
             <a:extLst xmlns:a="http://schemas.openxmlformats.org/drawingml/2006/main">
               <a:ext uri="{FF2B5EF4-FFF2-40B4-BE49-F238E27FC236}">
-                <a16:creationId xmlns:a16="http://schemas.microsoft.com/office/drawing/2014/main" id="{356271E0-78E1-44A6-A4BD-655AD4784374}"/>
+                <a16:creationId xmlns:a16="http://schemas.microsoft.com/office/drawing/2014/main" id="{9031C2FF-BC8B-4962-A75C-8DD398FA777F}"/>
               </a:ext>
             </a:extLst>
           </p:cNvPr>
@@ -4874,7 +4879,7 @@
           <p:nvPr/>
         </p:nvPicPr>
         <p:blipFill>
-          <a:blip xmlns:r="http://schemas.openxmlformats.org/officeDocument/2006/relationships" xmlns:a="http://schemas.openxmlformats.org/drawingml/2006/main" r:embed="R5852119e8f974801"/>
+          <a:blip xmlns:r="http://schemas.openxmlformats.org/officeDocument/2006/relationships" xmlns:a="http://schemas.openxmlformats.org/drawingml/2006/main" r:embed="R9b21d559252a4e6e"/>
           <a:stretch xmlns:a="http://schemas.openxmlformats.org/drawingml/2006/main"/>
         </p:blipFill>
         <p:spPr>
@@ -4890,7 +4895,7 @@
     </p:spTree>
     <p:extLst>
       <p:ext uri="{BB962C8B-B14F-4D97-AF65-F5344CB8AC3E}">
-        <p14:creationId xmlns:p14="http://schemas.microsoft.com/office/powerpoint/2010/main" val="107173139"/>
+        <p14:creationId xmlns:p14="http://schemas.microsoft.com/office/powerpoint/2010/main" val="1776169237"/>
       </p:ext>
     </p:extLst>
   </p:cSld>
@@ -4921,7 +4926,7 @@
           <p:cNvPr id="9" name="">
             <a:extLst xmlns:a="http://schemas.openxmlformats.org/drawingml/2006/main">
               <a:ext uri="{FF2B5EF4-FFF2-40B4-BE49-F238E27FC236}">
-                <a16:creationId xmlns:a16="http://schemas.microsoft.com/office/drawing/2014/main" id="{D773C7CB-28A9-4B06-84DD-EF528635B5DC}"/>
+                <a16:creationId xmlns:a16="http://schemas.microsoft.com/office/drawing/2014/main" id="{E452B5A5-6FF8-4109-B85B-A1274E408FDA}"/>
               </a:ext>
             </a:extLst>
           </p:cNvPr>
@@ -4978,7 +4983,7 @@
           <p:cNvPr id="2" name="">
             <a:extLst xmlns:a="http://schemas.openxmlformats.org/drawingml/2006/main">
               <a:ext uri="{FF2B5EF4-FFF2-40B4-BE49-F238E27FC236}">
-                <a16:creationId xmlns:a16="http://schemas.microsoft.com/office/drawing/2014/main" id="{87E68AD8-BD60-45CC-A263-048DCF748BC3}"/>
+                <a16:creationId xmlns:a16="http://schemas.microsoft.com/office/drawing/2014/main" id="{38B97356-6AC7-4A45-B37C-AE177D8AD53D}"/>
               </a:ext>
             </a:extLst>
           </p:cNvPr>
@@ -5039,7 +5044,7 @@
           <p:nvPr/>
         </p:nvPicPr>
         <p:blipFill>
-          <a:blip xmlns:r="http://schemas.openxmlformats.org/officeDocument/2006/relationships" xmlns:a="http://schemas.openxmlformats.org/drawingml/2006/main" r:embed="R7d329a19980543ea"/>
+          <a:blip xmlns:r="http://schemas.openxmlformats.org/officeDocument/2006/relationships" xmlns:a="http://schemas.openxmlformats.org/drawingml/2006/main" r:embed="Rca5d987e79d64527"/>
           <a:stretch xmlns:a="http://schemas.openxmlformats.org/drawingml/2006/main"/>
         </p:blipFill>
         <p:spPr>
@@ -5057,7 +5062,7 @@
           <p:cNvPr id="4" name="">
             <a:extLst xmlns:a="http://schemas.openxmlformats.org/drawingml/2006/main">
               <a:ext uri="{FF2B5EF4-FFF2-40B4-BE49-F238E27FC236}">
-                <a16:creationId xmlns:a16="http://schemas.microsoft.com/office/drawing/2014/main" id="{B77F73EB-064E-4052-9BDF-602413D7278C}"/>
+                <a16:creationId xmlns:a16="http://schemas.microsoft.com/office/drawing/2014/main" id="{E11C820E-83C4-4DFD-B982-8EA81EA045B2}"/>
               </a:ext>
             </a:extLst>
           </p:cNvPr>
@@ -5114,7 +5119,7 @@
           <p:cNvPr id="5" name="">
             <a:extLst xmlns:a="http://schemas.openxmlformats.org/drawingml/2006/main">
               <a:ext uri="{FF2B5EF4-FFF2-40B4-BE49-F238E27FC236}">
-                <a16:creationId xmlns:a16="http://schemas.microsoft.com/office/drawing/2014/main" id="{7F10ED19-21D6-4CDF-8E4B-FBE04E08CFDF}"/>
+                <a16:creationId xmlns:a16="http://schemas.microsoft.com/office/drawing/2014/main" id="{A4A4114A-2525-4E67-8CB7-F2DDD0F63A42}"/>
               </a:ext>
             </a:extLst>
           </p:cNvPr>
@@ -5194,7 +5199,7 @@
           <p:cNvPr id="6" name="">
             <a:extLst xmlns:a="http://schemas.openxmlformats.org/drawingml/2006/main">
               <a:ext uri="{FF2B5EF4-FFF2-40B4-BE49-F238E27FC236}">
-                <a16:creationId xmlns:a16="http://schemas.microsoft.com/office/drawing/2014/main" id="{42441686-4C47-4854-AAAA-82C9CBCAD9A8}"/>
+                <a16:creationId xmlns:a16="http://schemas.microsoft.com/office/drawing/2014/main" id="{19235528-7184-4B62-B09C-E15FF45481F7}"/>
               </a:ext>
             </a:extLst>
           </p:cNvPr>
@@ -5251,7 +5256,7 @@
           <p:cNvPr id="7" name="">
             <a:extLst xmlns:a="http://schemas.openxmlformats.org/drawingml/2006/main">
               <a:ext uri="{FF2B5EF4-FFF2-40B4-BE49-F238E27FC236}">
-                <a16:creationId xmlns:a16="http://schemas.microsoft.com/office/drawing/2014/main" id="{1331FE2D-6DD1-489D-BE5C-016991701A68}"/>
+                <a16:creationId xmlns:a16="http://schemas.microsoft.com/office/drawing/2014/main" id="{906902C7-37DC-4A2A-A9DA-547D6C414782}"/>
               </a:ext>
             </a:extLst>
           </p:cNvPr>
@@ -5331,7 +5336,7 @@
           <p:cNvPr id="8" name="">
             <a:extLst xmlns:a="http://schemas.openxmlformats.org/drawingml/2006/main">
               <a:ext uri="{FF2B5EF4-FFF2-40B4-BE49-F238E27FC236}">
-                <a16:creationId xmlns:a16="http://schemas.microsoft.com/office/drawing/2014/main" id="{CBBB48BB-002A-4091-8F30-7A22FDE30AFD}"/>
+                <a16:creationId xmlns:a16="http://schemas.microsoft.com/office/drawing/2014/main" id="{163B4108-C04F-4871-BB2F-7F535FF4E383}"/>
               </a:ext>
             </a:extLst>
           </p:cNvPr>
@@ -5386,7 +5391,7 @@
     </p:spTree>
     <p:extLst>
       <p:ext uri="{BB962C8B-B14F-4D97-AF65-F5344CB8AC3E}">
-        <p14:creationId xmlns:p14="http://schemas.microsoft.com/office/powerpoint/2010/main" val="1993725369"/>
+        <p14:creationId xmlns:p14="http://schemas.microsoft.com/office/powerpoint/2010/main" val="114062653"/>
       </p:ext>
     </p:extLst>
   </p:cSld>
@@ -5417,7 +5422,7 @@
           <p:cNvPr id="10" name="">
             <a:extLst xmlns:a="http://schemas.openxmlformats.org/drawingml/2006/main">
               <a:ext uri="{FF2B5EF4-FFF2-40B4-BE49-F238E27FC236}">
-                <a16:creationId xmlns:a16="http://schemas.microsoft.com/office/drawing/2014/main" id="{806B799D-A825-4717-B6A6-59326CD0AF62}"/>
+                <a16:creationId xmlns:a16="http://schemas.microsoft.com/office/drawing/2014/main" id="{1269EC8B-8C81-4740-8751-B65B7121214C}"/>
               </a:ext>
             </a:extLst>
           </p:cNvPr>
@@ -5474,7 +5479,7 @@
           <p:cNvPr id="2" name="">
             <a:extLst xmlns:a="http://schemas.openxmlformats.org/drawingml/2006/main">
               <a:ext uri="{FF2B5EF4-FFF2-40B4-BE49-F238E27FC236}">
-                <a16:creationId xmlns:a16="http://schemas.microsoft.com/office/drawing/2014/main" id="{8A1FBF07-C94F-40AE-8F36-87957254C0C7}"/>
+                <a16:creationId xmlns:a16="http://schemas.microsoft.com/office/drawing/2014/main" id="{CFD6C13A-351B-48D2-8244-FC6C254B0594}"/>
               </a:ext>
             </a:extLst>
           </p:cNvPr>
@@ -5531,7 +5536,7 @@
           <p:cNvPr id="3" name="">
             <a:extLst xmlns:a="http://schemas.openxmlformats.org/drawingml/2006/main">
               <a:ext uri="{FF2B5EF4-FFF2-40B4-BE49-F238E27FC236}">
-                <a16:creationId xmlns:a16="http://schemas.microsoft.com/office/drawing/2014/main" id="{B1620CFC-AA2C-49C4-A5E8-F214A01A2C71}"/>
+                <a16:creationId xmlns:a16="http://schemas.microsoft.com/office/drawing/2014/main" id="{67E7E3B2-7059-4F51-8ECA-A0BCF997CC29}"/>
               </a:ext>
             </a:extLst>
           </p:cNvPr>
@@ -5588,7 +5593,7 @@
           <p:cNvPr id="4" name="">
             <a:extLst xmlns:a="http://schemas.openxmlformats.org/drawingml/2006/main">
               <a:ext uri="{FF2B5EF4-FFF2-40B4-BE49-F238E27FC236}">
-                <a16:creationId xmlns:a16="http://schemas.microsoft.com/office/drawing/2014/main" id="{977F866A-1DF0-4370-99A6-F085E133A387}"/>
+                <a16:creationId xmlns:a16="http://schemas.microsoft.com/office/drawing/2014/main" id="{16C6F91B-6D13-4945-9983-200AA9556546}"/>
               </a:ext>
             </a:extLst>
           </p:cNvPr>
@@ -5691,7 +5696,7 @@
           <p:cNvPr id="5" name="">
             <a:extLst xmlns:a="http://schemas.openxmlformats.org/drawingml/2006/main">
               <a:ext uri="{FF2B5EF4-FFF2-40B4-BE49-F238E27FC236}">
-                <a16:creationId xmlns:a16="http://schemas.microsoft.com/office/drawing/2014/main" id="{A0956D3D-D5BB-41B1-80B8-5E34281D0AAE}"/>
+                <a16:creationId xmlns:a16="http://schemas.microsoft.com/office/drawing/2014/main" id="{A0BDCA5F-A620-4AD3-B5CB-C3C2D29A3A02}"/>
               </a:ext>
             </a:extLst>
           </p:cNvPr>
@@ -5794,7 +5799,7 @@
           <p:cNvPr id="6" name="">
             <a:extLst xmlns:a="http://schemas.openxmlformats.org/drawingml/2006/main">
               <a:ext uri="{FF2B5EF4-FFF2-40B4-BE49-F238E27FC236}">
-                <a16:creationId xmlns:a16="http://schemas.microsoft.com/office/drawing/2014/main" id="{592D95B3-1D23-4518-9D70-004C95878DA4}"/>
+                <a16:creationId xmlns:a16="http://schemas.microsoft.com/office/drawing/2014/main" id="{4AD9FF0E-1DB5-489B-9857-AC7F292E5169}"/>
               </a:ext>
             </a:extLst>
           </p:cNvPr>
@@ -5851,7 +5856,7 @@
           <p:cNvPr id="7" name="">
             <a:extLst xmlns:a="http://schemas.openxmlformats.org/drawingml/2006/main">
               <a:ext uri="{FF2B5EF4-FFF2-40B4-BE49-F238E27FC236}">
-                <a16:creationId xmlns:a16="http://schemas.microsoft.com/office/drawing/2014/main" id="{2DADDDAC-1865-449B-B532-8A269C51F85C}"/>
+                <a16:creationId xmlns:a16="http://schemas.microsoft.com/office/drawing/2014/main" id="{17C31F1D-B092-469F-A249-6C98E1EDC663}"/>
               </a:ext>
             </a:extLst>
           </p:cNvPr>
@@ -5912,7 +5917,7 @@
           <p:nvPr/>
         </p:nvPicPr>
         <p:blipFill>
-          <a:blip xmlns:r="http://schemas.openxmlformats.org/officeDocument/2006/relationships" xmlns:a="http://schemas.openxmlformats.org/drawingml/2006/main" r:embed="R806e8e1e1c1c4200"/>
+          <a:blip xmlns:r="http://schemas.openxmlformats.org/officeDocument/2006/relationships" xmlns:a="http://schemas.openxmlformats.org/drawingml/2006/main" r:embed="R7864bcd7f33344e6"/>
           <a:stretch xmlns:a="http://schemas.openxmlformats.org/drawingml/2006/main"/>
         </p:blipFill>
         <p:spPr>
@@ -5934,7 +5939,7 @@
           <p:nvPr/>
         </p:nvPicPr>
         <p:blipFill>
-          <a:blip xmlns:r="http://schemas.openxmlformats.org/officeDocument/2006/relationships" xmlns:a="http://schemas.openxmlformats.org/drawingml/2006/main" r:embed="R26ac0357b1264b0b"/>
+          <a:blip xmlns:r="http://schemas.openxmlformats.org/officeDocument/2006/relationships" xmlns:a="http://schemas.openxmlformats.org/drawingml/2006/main" r:embed="R8ab18a4f01b74859"/>
           <a:stretch xmlns:a="http://schemas.openxmlformats.org/drawingml/2006/main"/>
         </p:blipFill>
         <p:spPr>
@@ -5950,7 +5955,7 @@
     </p:spTree>
     <p:extLst>
       <p:ext uri="{BB962C8B-B14F-4D97-AF65-F5344CB8AC3E}">
-        <p14:creationId xmlns:p14="http://schemas.microsoft.com/office/powerpoint/2010/main" val="351427784"/>
+        <p14:creationId xmlns:p14="http://schemas.microsoft.com/office/powerpoint/2010/main" val="1736987920"/>
       </p:ext>
     </p:extLst>
   </p:cSld>
@@ -5981,7 +5986,7 @@
           <p:cNvPr id="6" name="">
             <a:extLst xmlns:a="http://schemas.openxmlformats.org/drawingml/2006/main">
               <a:ext uri="{FF2B5EF4-FFF2-40B4-BE49-F238E27FC236}">
-                <a16:creationId xmlns:a16="http://schemas.microsoft.com/office/drawing/2014/main" id="{4EE7C5B4-8525-4812-AF5F-1C45AEE2FB6D}"/>
+                <a16:creationId xmlns:a16="http://schemas.microsoft.com/office/drawing/2014/main" id="{19271203-F32E-44D5-8393-3ECA3B6542B0}"/>
               </a:ext>
             </a:extLst>
           </p:cNvPr>
@@ -6038,7 +6043,7 @@
           <p:cNvPr id="2" name="">
             <a:extLst xmlns:a="http://schemas.openxmlformats.org/drawingml/2006/main">
               <a:ext uri="{FF2B5EF4-FFF2-40B4-BE49-F238E27FC236}">
-                <a16:creationId xmlns:a16="http://schemas.microsoft.com/office/drawing/2014/main" id="{8AC3A208-B26D-4EDC-8453-63833FF1F763}"/>
+                <a16:creationId xmlns:a16="http://schemas.microsoft.com/office/drawing/2014/main" id="{307053AE-BC77-4BDD-9C32-0F0124B3C134}"/>
               </a:ext>
             </a:extLst>
           </p:cNvPr>
@@ -6095,7 +6100,7 @@
           <p:cNvPr id="3" name="">
             <a:extLst xmlns:a="http://schemas.openxmlformats.org/drawingml/2006/main">
               <a:ext uri="{FF2B5EF4-FFF2-40B4-BE49-F238E27FC236}">
-                <a16:creationId xmlns:a16="http://schemas.microsoft.com/office/drawing/2014/main" id="{25E6438F-AD48-40A5-BB46-864AB0188D07}"/>
+                <a16:creationId xmlns:a16="http://schemas.microsoft.com/office/drawing/2014/main" id="{034C2A89-26E3-4F17-AA89-340A3DE3DD26}"/>
               </a:ext>
             </a:extLst>
           </p:cNvPr>
@@ -6605,7 +6610,7 @@
           <p:cNvPr id="5" name="">
             <a:extLst xmlns:a="http://schemas.openxmlformats.org/drawingml/2006/main">
               <a:ext uri="{FF2B5EF4-FFF2-40B4-BE49-F238E27FC236}">
-                <a16:creationId xmlns:a16="http://schemas.microsoft.com/office/drawing/2014/main" id="{AA30CCE4-EF7E-4B06-83BE-AF56F77B764A}"/>
+                <a16:creationId xmlns:a16="http://schemas.microsoft.com/office/drawing/2014/main" id="{7FE19B0E-50C9-4B73-9031-77025119B5AD}"/>
               </a:ext>
             </a:extLst>
           </p:cNvPr>
@@ -6660,7 +6665,7 @@
     </p:spTree>
     <p:extLst>
       <p:ext uri="{BB962C8B-B14F-4D97-AF65-F5344CB8AC3E}">
-        <p14:creationId xmlns:p14="http://schemas.microsoft.com/office/powerpoint/2010/main" val="2086168124"/>
+        <p14:creationId xmlns:p14="http://schemas.microsoft.com/office/powerpoint/2010/main" val="367293417"/>
       </p:ext>
     </p:extLst>
   </p:cSld>
@@ -6691,7 +6696,7 @@
           <p:cNvPr id="9" name="">
             <a:extLst xmlns:a="http://schemas.openxmlformats.org/drawingml/2006/main">
               <a:ext uri="{FF2B5EF4-FFF2-40B4-BE49-F238E27FC236}">
-                <a16:creationId xmlns:a16="http://schemas.microsoft.com/office/drawing/2014/main" id="{063416A6-8014-4252-BAB3-2023F0DCE510}"/>
+                <a16:creationId xmlns:a16="http://schemas.microsoft.com/office/drawing/2014/main" id="{349074FD-AF0F-4F58-A6C4-3E71AD344CC0}"/>
               </a:ext>
             </a:extLst>
           </p:cNvPr>
@@ -6748,7 +6753,7 @@
           <p:cNvPr id="2" name="">
             <a:extLst xmlns:a="http://schemas.openxmlformats.org/drawingml/2006/main">
               <a:ext uri="{FF2B5EF4-FFF2-40B4-BE49-F238E27FC236}">
-                <a16:creationId xmlns:a16="http://schemas.microsoft.com/office/drawing/2014/main" id="{DA7D1D0B-F4D5-4938-9E3A-E87D8658C438}"/>
+                <a16:creationId xmlns:a16="http://schemas.microsoft.com/office/drawing/2014/main" id="{B4F93783-14C7-4B1A-A136-486DCFE4E486}"/>
               </a:ext>
             </a:extLst>
           </p:cNvPr>
@@ -6805,7 +6810,7 @@
           <p:cNvPr id="3" name="">
             <a:extLst xmlns:a="http://schemas.openxmlformats.org/drawingml/2006/main">
               <a:ext uri="{FF2B5EF4-FFF2-40B4-BE49-F238E27FC236}">
-                <a16:creationId xmlns:a16="http://schemas.microsoft.com/office/drawing/2014/main" id="{52E7DB7D-70D5-44A6-8DF5-A136BF48DB2E}"/>
+                <a16:creationId xmlns:a16="http://schemas.microsoft.com/office/drawing/2014/main" id="{44ACD0C5-A593-40B2-A5CF-BA004181CDE1}"/>
               </a:ext>
             </a:extLst>
           </p:cNvPr>
@@ -6862,7 +6867,7 @@
           <p:cNvPr id="4" name="">
             <a:extLst xmlns:a="http://schemas.openxmlformats.org/drawingml/2006/main">
               <a:ext uri="{FF2B5EF4-FFF2-40B4-BE49-F238E27FC236}">
-                <a16:creationId xmlns:a16="http://schemas.microsoft.com/office/drawing/2014/main" id="{8D2C342F-07F6-41A2-BDE2-B8E11691007F}"/>
+                <a16:creationId xmlns:a16="http://schemas.microsoft.com/office/drawing/2014/main" id="{1C39F1C0-50DB-46C3-83FA-E4EA6B2E1E08}"/>
               </a:ext>
             </a:extLst>
           </p:cNvPr>
@@ -6919,7 +6924,7 @@
           <p:cNvPr id="5" name="">
             <a:extLst xmlns:a="http://schemas.openxmlformats.org/drawingml/2006/main">
               <a:ext uri="{FF2B5EF4-FFF2-40B4-BE49-F238E27FC236}">
-                <a16:creationId xmlns:a16="http://schemas.microsoft.com/office/drawing/2014/main" id="{F957634E-C5EB-4984-8CDD-ECF315387FC0}"/>
+                <a16:creationId xmlns:a16="http://schemas.microsoft.com/office/drawing/2014/main" id="{CEE4EF87-756E-46DB-8256-761233958292}"/>
               </a:ext>
             </a:extLst>
           </p:cNvPr>
@@ -7022,7 +7027,7 @@
           <p:cNvPr id="6" name="">
             <a:extLst xmlns:a="http://schemas.openxmlformats.org/drawingml/2006/main">
               <a:ext uri="{FF2B5EF4-FFF2-40B4-BE49-F238E27FC236}">
-                <a16:creationId xmlns:a16="http://schemas.microsoft.com/office/drawing/2014/main" id="{7B2CF585-AD2D-4C64-821F-C4FA2A6C6894}"/>
+                <a16:creationId xmlns:a16="http://schemas.microsoft.com/office/drawing/2014/main" id="{A4138365-6C5E-4544-8CA7-255F18B54EFC}"/>
               </a:ext>
             </a:extLst>
           </p:cNvPr>
@@ -7079,7 +7084,7 @@
           <p:cNvPr id="7" name="">
             <a:extLst xmlns:a="http://schemas.openxmlformats.org/drawingml/2006/main">
               <a:ext uri="{FF2B5EF4-FFF2-40B4-BE49-F238E27FC236}">
-                <a16:creationId xmlns:a16="http://schemas.microsoft.com/office/drawing/2014/main" id="{620EC957-E466-4276-835A-DAB1AFF847A5}"/>
+                <a16:creationId xmlns:a16="http://schemas.microsoft.com/office/drawing/2014/main" id="{B884866F-6912-4F97-9584-A900CFDE077D}"/>
               </a:ext>
             </a:extLst>
           </p:cNvPr>
@@ -7205,7 +7210,7 @@
           <p:cNvPr id="8" name="">
             <a:extLst xmlns:a="http://schemas.openxmlformats.org/drawingml/2006/main">
               <a:ext uri="{FF2B5EF4-FFF2-40B4-BE49-F238E27FC236}">
-                <a16:creationId xmlns:a16="http://schemas.microsoft.com/office/drawing/2014/main" id="{5E517A13-DED6-4C7B-AE1D-4F3AE45EB982}"/>
+                <a16:creationId xmlns:a16="http://schemas.microsoft.com/office/drawing/2014/main" id="{3153FE0A-1DA7-48F1-80E1-2A12F7404007}"/>
               </a:ext>
             </a:extLst>
           </p:cNvPr>
@@ -7283,7 +7288,7 @@
     </p:spTree>
     <p:extLst>
       <p:ext uri="{BB962C8B-B14F-4D97-AF65-F5344CB8AC3E}">
-        <p14:creationId xmlns:p14="http://schemas.microsoft.com/office/powerpoint/2010/main" val="662198175"/>
+        <p14:creationId xmlns:p14="http://schemas.microsoft.com/office/powerpoint/2010/main" val="795363001"/>
       </p:ext>
     </p:extLst>
   </p:cSld>
@@ -7311,10 +7316,10 @@
       </p:grpSpPr>
       <p:sp>
         <p:nvSpPr>
-          <p:cNvPr id="12" name="">
+          <p:cNvPr id="10" name="">
             <a:extLst xmlns:a="http://schemas.openxmlformats.org/drawingml/2006/main">
               <a:ext uri="{FF2B5EF4-FFF2-40B4-BE49-F238E27FC236}">
-                <a16:creationId xmlns:a16="http://schemas.microsoft.com/office/drawing/2014/main" id="{E3AB3D0D-9869-4890-8D07-CA4CEBC4DEE7}"/>
+                <a16:creationId xmlns:a16="http://schemas.microsoft.com/office/drawing/2014/main" id="{1306F4C5-7CE3-47D5-963F-9B056C44B1B6}"/>
               </a:ext>
             </a:extLst>
           </p:cNvPr>
@@ -7371,7 +7376,7 @@
           <p:cNvPr id="2" name="">
             <a:extLst xmlns:a="http://schemas.openxmlformats.org/drawingml/2006/main">
               <a:ext uri="{FF2B5EF4-FFF2-40B4-BE49-F238E27FC236}">
-                <a16:creationId xmlns:a16="http://schemas.microsoft.com/office/drawing/2014/main" id="{A09BDF87-4E87-4F20-9F74-863E3B0B97BC}"/>
+                <a16:creationId xmlns:a16="http://schemas.microsoft.com/office/drawing/2014/main" id="{6E9DD13E-02C7-4A2E-8F06-E410D494B1E1}"/>
               </a:ext>
             </a:extLst>
           </p:cNvPr>
@@ -7418,7 +7423,7 @@
                 <a:ea typeface="Newsreader"/>
                 <a:cs typeface="Newsreader"/>
               </a:rPr>
-              <a:t>Der nächste Beweis: Alltag</a:t>
+              <a:t>Rückblick und Ausblick</a:t>
             </a:r>
           </a:p>
         </p:txBody>
@@ -7428,7 +7433,7 @@
           <p:cNvPr id="3" name="">
             <a:extLst xmlns:a="http://schemas.openxmlformats.org/drawingml/2006/main">
               <a:ext uri="{FF2B5EF4-FFF2-40B4-BE49-F238E27FC236}">
-                <a16:creationId xmlns:a16="http://schemas.microsoft.com/office/drawing/2014/main" id="{65C7381F-A525-4B91-9EF9-428FB348608B}"/>
+                <a16:creationId xmlns:a16="http://schemas.microsoft.com/office/drawing/2014/main" id="{E0F728BB-D44F-4A52-BBCB-7F77D3AF724A}"/>
               </a:ext>
             </a:extLst>
           </p:cNvPr>
@@ -7439,8 +7444,8 @@
         </p:nvSpPr>
         <p:spPr>
           <a:xfrm xmlns:a="http://schemas.openxmlformats.org/drawingml/2006/main">
-            <a:off x="628650" y="1638300"/>
-            <a:ext cx="3429000" cy="1685925"/>
+            <a:off x="628650" y="1762125"/>
+            <a:ext cx="5162550" cy="838200"/>
           </a:xfrm>
           <a:prstGeom xmlns:a="http://schemas.openxmlformats.org/drawingml/2006/main" prst="rect">
             <a:avLst/>
@@ -7457,7 +7462,7 @@
           <a:lstStyle xmlns:a="http://schemas.openxmlformats.org/drawingml/2006/main"/>
           <a:p xmlns:a="http://schemas.openxmlformats.org/drawingml/2006/main">
             <a:pPr algn="l">
-              <a:defRPr sz="10575" b="0">
+              <a:defRPr sz="2850" b="0">
                 <a:solidFill>
                   <a:srgbClr val="1F5A45"/>
                 </a:solidFill>
@@ -7467,7 +7472,7 @@
               </a:defRPr>
             </a:pPr>
             <a:r>
-              <a:rPr sz="10575" b="0">
+              <a:rPr sz="2850" b="0">
                 <a:solidFill>
                   <a:srgbClr val="1F5A45"/>
                 </a:solidFill>
@@ -7475,7 +7480,7 @@
                 <a:ea typeface="Newsreader"/>
                 <a:cs typeface="Newsreader"/>
               </a:rPr>
-              <a:t>5</a:t>
+              <a:t>Was wir gelernt haben</a:t>
             </a:r>
           </a:p>
         </p:txBody>
@@ -7485,7 +7490,7 @@
           <p:cNvPr id="4" name="">
             <a:extLst xmlns:a="http://schemas.openxmlformats.org/drawingml/2006/main">
               <a:ext uri="{FF2B5EF4-FFF2-40B4-BE49-F238E27FC236}">
-                <a16:creationId xmlns:a16="http://schemas.microsoft.com/office/drawing/2014/main" id="{20F42D9B-CE39-48AA-8E8A-88ED37CC2D38}"/>
+                <a16:creationId xmlns:a16="http://schemas.microsoft.com/office/drawing/2014/main" id="{4EB8995F-6DC7-4C70-9431-BD3B35DD5F72}"/>
               </a:ext>
             </a:extLst>
           </p:cNvPr>
@@ -7496,8 +7501,8 @@
         </p:nvSpPr>
         <p:spPr>
           <a:xfrm xmlns:a="http://schemas.openxmlformats.org/drawingml/2006/main">
-            <a:off x="666750" y="3429000"/>
-            <a:ext cx="5172075" cy="685800"/>
+            <a:off x="666750" y="2876550"/>
+            <a:ext cx="5095875" cy="1009650"/>
           </a:xfrm>
           <a:prstGeom xmlns:a="http://schemas.openxmlformats.org/drawingml/2006/main" prst="rect">
             <a:avLst/>
@@ -7532,7 +7537,30 @@
                 <a:ea typeface="Inter"/>
                 <a:cs typeface="Inter"/>
               </a:rPr>
-              <a:t>Lernende oder Studierende</a:t>
+              <a:t>Monatsbudgets und Fristen</a:t>
+            </a:r>
+          </a:p>
+          <a:p xmlns:a="http://schemas.openxmlformats.org/drawingml/2006/main">
+            <a:pPr algn="l">
+              <a:defRPr sz="2175" b="0">
+                <a:solidFill>
+                  <a:srgbClr val="15171A"/>
+                </a:solidFill>
+                <a:latin typeface="Inter"/>
+                <a:ea typeface="Inter"/>
+                <a:cs typeface="Inter"/>
+              </a:defRPr>
+            </a:pPr>
+            <a:r>
+              <a:rPr sz="2175" b="0">
+                <a:solidFill>
+                  <a:srgbClr val="15171A"/>
+                </a:solidFill>
+                <a:latin typeface="Inter"/>
+                <a:ea typeface="Inter"/>
+                <a:cs typeface="Inter"/>
+              </a:rPr>
+              <a:t>brauchen klare Regeln.</a:t>
             </a:r>
           </a:p>
         </p:txBody>
@@ -7542,7 +7570,7 @@
           <p:cNvPr id="5" name="">
             <a:extLst xmlns:a="http://schemas.openxmlformats.org/drawingml/2006/main">
               <a:ext uri="{FF2B5EF4-FFF2-40B4-BE49-F238E27FC236}">
-                <a16:creationId xmlns:a16="http://schemas.microsoft.com/office/drawing/2014/main" id="{70E3F2B8-E084-4E3B-BA19-72B1DE7BDD7C}"/>
+                <a16:creationId xmlns:a16="http://schemas.microsoft.com/office/drawing/2014/main" id="{CE243F8F-8201-4762-B886-2D6044B448EF}"/>
               </a:ext>
             </a:extLst>
           </p:cNvPr>
@@ -7553,8 +7581,8 @@
         </p:nvSpPr>
         <p:spPr>
           <a:xfrm xmlns:a="http://schemas.openxmlformats.org/drawingml/2006/main">
-            <a:off x="666750" y="4419600"/>
-            <a:ext cx="5133975" cy="542925"/>
+            <a:off x="666750" y="4543425"/>
+            <a:ext cx="5095875" cy="1009650"/>
           </a:xfrm>
           <a:prstGeom xmlns:a="http://schemas.openxmlformats.org/drawingml/2006/main" prst="rect">
             <a:avLst/>
@@ -7571,25 +7599,48 @@
           <a:lstStyle xmlns:a="http://schemas.openxmlformats.org/drawingml/2006/main"/>
           <a:p xmlns:a="http://schemas.openxmlformats.org/drawingml/2006/main">
             <a:pPr algn="l">
-              <a:defRPr sz="2550" b="0">
-                <a:solidFill>
-                  <a:srgbClr val="1F5A45"/>
-                </a:solidFill>
-                <a:latin typeface="Newsreader"/>
-                <a:ea typeface="Newsreader"/>
-                <a:cs typeface="Newsreader"/>
-              </a:defRPr>
-            </a:pPr>
-            <a:r>
-              <a:rPr sz="2550" b="0">
-                <a:solidFill>
-                  <a:srgbClr val="1F5A45"/>
-                </a:solidFill>
-                <a:latin typeface="Newsreader"/>
-                <a:ea typeface="Newsreader"/>
-                <a:cs typeface="Newsreader"/>
-              </a:rPr>
-              <a:t>1 Woche mit Spendly</a:t>
+              <a:defRPr sz="2175" b="0">
+                <a:solidFill>
+                  <a:srgbClr val="15171A"/>
+                </a:solidFill>
+                <a:latin typeface="Inter"/>
+                <a:ea typeface="Inter"/>
+                <a:cs typeface="Inter"/>
+              </a:defRPr>
+            </a:pPr>
+            <a:r>
+              <a:rPr sz="2175" b="0">
+                <a:solidFill>
+                  <a:srgbClr val="15171A"/>
+                </a:solidFill>
+                <a:latin typeface="Inter"/>
+                <a:ea typeface="Inter"/>
+                <a:cs typeface="Inter"/>
+              </a:rPr>
+              <a:t>Fehlerfälle und Neustarts</a:t>
+            </a:r>
+          </a:p>
+          <a:p xmlns:a="http://schemas.openxmlformats.org/drawingml/2006/main">
+            <a:pPr algn="l">
+              <a:defRPr sz="2175" b="0">
+                <a:solidFill>
+                  <a:srgbClr val="15171A"/>
+                </a:solidFill>
+                <a:latin typeface="Inter"/>
+                <a:ea typeface="Inter"/>
+                <a:cs typeface="Inter"/>
+              </a:defRPr>
+            </a:pPr>
+            <a:r>
+              <a:rPr sz="2175" b="0">
+                <a:solidFill>
+                  <a:srgbClr val="15171A"/>
+                </a:solidFill>
+                <a:latin typeface="Inter"/>
+                <a:ea typeface="Inter"/>
+                <a:cs typeface="Inter"/>
+              </a:rPr>
+              <a:t>früher im Entwurf mitdenken.</a:t>
             </a:r>
           </a:p>
         </p:txBody>
@@ -7599,7 +7650,7 @@
           <p:cNvPr id="6" name="">
             <a:extLst xmlns:a="http://schemas.openxmlformats.org/drawingml/2006/main">
               <a:ext uri="{FF2B5EF4-FFF2-40B4-BE49-F238E27FC236}">
-                <a16:creationId xmlns:a16="http://schemas.microsoft.com/office/drawing/2014/main" id="{C0423CC8-F1BD-4D6D-AE67-37DF605EAB04}"/>
+                <a16:creationId xmlns:a16="http://schemas.microsoft.com/office/drawing/2014/main" id="{A4F787A6-AFC3-468A-8C03-29FBC2A8FA8D}"/>
               </a:ext>
             </a:extLst>
           </p:cNvPr>
@@ -7610,8 +7661,8 @@
         </p:nvSpPr>
         <p:spPr>
           <a:xfrm xmlns:a="http://schemas.openxmlformats.org/drawingml/2006/main">
-            <a:off x="666750" y="5295900"/>
-            <a:ext cx="5076825" cy="400050"/>
+            <a:off x="6419850" y="1762125"/>
+            <a:ext cx="5124450" cy="838200"/>
           </a:xfrm>
           <a:prstGeom xmlns:a="http://schemas.openxmlformats.org/drawingml/2006/main" prst="rect">
             <a:avLst/>
@@ -7628,25 +7679,25 @@
           <a:lstStyle xmlns:a="http://schemas.openxmlformats.org/drawingml/2006/main"/>
           <a:p xmlns:a="http://schemas.openxmlformats.org/drawingml/2006/main">
             <a:pPr algn="l">
-              <a:defRPr sz="1725" b="0">
-                <a:solidFill>
-                  <a:srgbClr val="6E6D68"/>
-                </a:solidFill>
-                <a:latin typeface="Inter"/>
-                <a:ea typeface="Inter"/>
-                <a:cs typeface="Inter"/>
-              </a:defRPr>
-            </a:pPr>
-            <a:r>
-              <a:rPr sz="1725" b="0">
-                <a:solidFill>
-                  <a:srgbClr val="6E6D68"/>
-                </a:solidFill>
-                <a:latin typeface="Inter"/>
-                <a:ea typeface="Inter"/>
-                <a:cs typeface="Inter"/>
-              </a:rPr>
-              <a:t>Geplante Testphase</a:t>
+              <a:defRPr sz="2850" b="0">
+                <a:solidFill>
+                  <a:srgbClr val="1F5A45"/>
+                </a:solidFill>
+                <a:latin typeface="Newsreader"/>
+                <a:ea typeface="Newsreader"/>
+                <a:cs typeface="Newsreader"/>
+              </a:defRPr>
+            </a:pPr>
+            <a:r>
+              <a:rPr sz="2850" b="0">
+                <a:solidFill>
+                  <a:srgbClr val="1F5A45"/>
+                </a:solidFill>
+                <a:latin typeface="Newsreader"/>
+                <a:ea typeface="Newsreader"/>
+                <a:cs typeface="Newsreader"/>
+              </a:rPr>
+              <a:t>Mögliche Erweiterungen</a:t>
             </a:r>
           </a:p>
         </p:txBody>
@@ -7656,7 +7707,7 @@
           <p:cNvPr id="7" name="">
             <a:extLst xmlns:a="http://schemas.openxmlformats.org/drawingml/2006/main">
               <a:ext uri="{FF2B5EF4-FFF2-40B4-BE49-F238E27FC236}">
-                <a16:creationId xmlns:a16="http://schemas.microsoft.com/office/drawing/2014/main" id="{B738FD79-5B30-455B-99AD-9312E9D57E86}"/>
+                <a16:creationId xmlns:a16="http://schemas.microsoft.com/office/drawing/2014/main" id="{02CD1449-9F6F-491B-B3B9-9CFB12835304}"/>
               </a:ext>
             </a:extLst>
           </p:cNvPr>
@@ -7667,8 +7718,8 @@
         </p:nvSpPr>
         <p:spPr>
           <a:xfrm xmlns:a="http://schemas.openxmlformats.org/drawingml/2006/main">
-            <a:off x="6400800" y="1838325"/>
-            <a:ext cx="5143500" cy="838200"/>
+            <a:off x="6467475" y="2914650"/>
+            <a:ext cx="5076825" cy="714375"/>
           </a:xfrm>
           <a:prstGeom xmlns:a="http://schemas.openxmlformats.org/drawingml/2006/main" prst="rect">
             <a:avLst/>
@@ -7685,25 +7736,25 @@
           <a:lstStyle xmlns:a="http://schemas.openxmlformats.org/drawingml/2006/main"/>
           <a:p xmlns:a="http://schemas.openxmlformats.org/drawingml/2006/main">
             <a:pPr algn="l">
-              <a:defRPr sz="2625" b="0">
-                <a:solidFill>
-                  <a:srgbClr val="1F5A45"/>
-                </a:solidFill>
-                <a:latin typeface="Newsreader"/>
-                <a:ea typeface="Newsreader"/>
-                <a:cs typeface="Newsreader"/>
-              </a:defRPr>
-            </a:pPr>
-            <a:r>
-              <a:rPr sz="2625" b="0">
-                <a:solidFill>
-                  <a:srgbClr val="1F5A45"/>
-                </a:solidFill>
-                <a:latin typeface="Newsreader"/>
-                <a:ea typeface="Newsreader"/>
-                <a:cs typeface="Newsreader"/>
-              </a:rPr>
-              <a:t>Was wir herausfinden wollen</a:t>
+              <a:defRPr sz="2175" b="0">
+                <a:solidFill>
+                  <a:srgbClr val="15171A"/>
+                </a:solidFill>
+                <a:latin typeface="Inter"/>
+                <a:ea typeface="Inter"/>
+                <a:cs typeface="Inter"/>
+              </a:defRPr>
+            </a:pPr>
+            <a:r>
+              <a:rPr sz="2175" b="0">
+                <a:solidFill>
+                  <a:srgbClr val="15171A"/>
+                </a:solidFill>
+                <a:latin typeface="Inter"/>
+                <a:ea typeface="Inter"/>
+                <a:cs typeface="Inter"/>
+              </a:rPr>
+              <a:t>Ausgaben als CSV exportieren</a:t>
             </a:r>
           </a:p>
         </p:txBody>
@@ -7713,7 +7764,7 @@
           <p:cNvPr id="8" name="">
             <a:extLst xmlns:a="http://schemas.openxmlformats.org/drawingml/2006/main">
               <a:ext uri="{FF2B5EF4-FFF2-40B4-BE49-F238E27FC236}">
-                <a16:creationId xmlns:a16="http://schemas.microsoft.com/office/drawing/2014/main" id="{F1DFED6A-0026-42E5-8493-24C8990E85AE}"/>
+                <a16:creationId xmlns:a16="http://schemas.microsoft.com/office/drawing/2014/main" id="{43AC2C48-54AA-4595-9E3A-4BB8DB254EFE}"/>
               </a:ext>
             </a:extLst>
           </p:cNvPr>
@@ -7724,8 +7775,8 @@
         </p:nvSpPr>
         <p:spPr>
           <a:xfrm xmlns:a="http://schemas.openxmlformats.org/drawingml/2006/main">
-            <a:off x="6457950" y="3105150"/>
-            <a:ext cx="5095875" cy="619125"/>
+            <a:off x="6467475" y="4095750"/>
+            <a:ext cx="5076825" cy="714375"/>
           </a:xfrm>
           <a:prstGeom xmlns:a="http://schemas.openxmlformats.org/drawingml/2006/main" prst="rect">
             <a:avLst/>
@@ -7742,7 +7793,7 @@
           <a:lstStyle xmlns:a="http://schemas.openxmlformats.org/drawingml/2006/main"/>
           <a:p xmlns:a="http://schemas.openxmlformats.org/drawingml/2006/main">
             <a:pPr algn="l">
-              <a:defRPr sz="2100" b="0">
+              <a:defRPr sz="2175" b="0">
                 <a:solidFill>
                   <a:srgbClr val="15171A"/>
                 </a:solidFill>
@@ -7752,7 +7803,7 @@
               </a:defRPr>
             </a:pPr>
             <a:r>
-              <a:rPr sz="2100" b="0">
+              <a:rPr sz="2175" b="0">
                 <a:solidFill>
                   <a:srgbClr val="15171A"/>
                 </a:solidFill>
@@ -7760,7 +7811,7 @@
                 <a:ea typeface="Inter"/>
                 <a:cs typeface="Inter"/>
               </a:rPr>
-              <a:t>Wie schnell gelingt eine Erfassung?</a:t>
+              <a:t>Statistiken nach Kategorien</a:t>
             </a:r>
           </a:p>
         </p:txBody>
@@ -7770,7 +7821,7 @@
           <p:cNvPr id="9" name="">
             <a:extLst xmlns:a="http://schemas.openxmlformats.org/drawingml/2006/main">
               <a:ext uri="{FF2B5EF4-FFF2-40B4-BE49-F238E27FC236}">
-                <a16:creationId xmlns:a16="http://schemas.microsoft.com/office/drawing/2014/main" id="{8D99ABDE-EAFF-4B8C-A066-840FE1F6E641}"/>
+                <a16:creationId xmlns:a16="http://schemas.microsoft.com/office/drawing/2014/main" id="{438FEB1C-EB8B-4AA4-800A-5AC034B9D5CB}"/>
               </a:ext>
             </a:extLst>
           </p:cNvPr>
@@ -7781,8 +7832,8 @@
         </p:nvSpPr>
         <p:spPr>
           <a:xfrm xmlns:a="http://schemas.openxmlformats.org/drawingml/2006/main">
-            <a:off x="6457950" y="3867150"/>
-            <a:ext cx="5095875" cy="619125"/>
+            <a:off x="6457950" y="5495925"/>
+            <a:ext cx="5095875" cy="695325"/>
           </a:xfrm>
           <a:prstGeom xmlns:a="http://schemas.openxmlformats.org/drawingml/2006/main" prst="rect">
             <a:avLst/>
@@ -7799,121 +7850,30 @@
           <a:lstStyle xmlns:a="http://schemas.openxmlformats.org/drawingml/2006/main"/>
           <a:p xmlns:a="http://schemas.openxmlformats.org/drawingml/2006/main">
             <a:pPr algn="l">
-              <a:defRPr sz="2100" b="0">
-                <a:solidFill>
-                  <a:srgbClr val="15171A"/>
-                </a:solidFill>
-                <a:latin typeface="Inter"/>
-                <a:ea typeface="Inter"/>
-                <a:cs typeface="Inter"/>
-              </a:defRPr>
-            </a:pPr>
-            <a:r>
-              <a:rPr sz="2100" b="0">
-                <a:solidFill>
-                  <a:srgbClr val="15171A"/>
-                </a:solidFill>
-                <a:latin typeface="Inter"/>
-                <a:ea typeface="Inter"/>
-                <a:cs typeface="Inter"/>
-              </a:rPr>
-              <a:t>Wie verständlich ist der Tagesbetrag?</a:t>
-            </a:r>
-          </a:p>
-        </p:txBody>
-      </p:sp>
-      <p:sp>
-        <p:nvSpPr>
-          <p:cNvPr id="10" name="">
-            <a:extLst xmlns:a="http://schemas.openxmlformats.org/drawingml/2006/main">
-              <a:ext uri="{FF2B5EF4-FFF2-40B4-BE49-F238E27FC236}">
-                <a16:creationId xmlns:a16="http://schemas.microsoft.com/office/drawing/2014/main" id="{954EFA87-C14B-4CBD-9469-603B6BEFD81A}"/>
-              </a:ext>
-            </a:extLst>
-          </p:cNvPr>
-          <p:cNvSpPr>
-            <a:spLocks xmlns:a="http://schemas.openxmlformats.org/drawingml/2006/main" noGrp="1"/>
-          </p:cNvSpPr>
-          <p:nvPr/>
-        </p:nvSpPr>
-        <p:spPr>
-          <a:xfrm xmlns:a="http://schemas.openxmlformats.org/drawingml/2006/main">
-            <a:off x="6457950" y="4629150"/>
-            <a:ext cx="5095875" cy="619125"/>
-          </a:xfrm>
-          <a:prstGeom xmlns:a="http://schemas.openxmlformats.org/drawingml/2006/main" prst="rect">
-            <a:avLst/>
-          </a:prstGeom>
-          <a:noFill xmlns:a="http://schemas.openxmlformats.org/drawingml/2006/main"/>
-          <a:ln xmlns:a="http://schemas.openxmlformats.org/drawingml/2006/main" w="0">
-            <a:noFill/>
-          </a:ln>
-        </p:spPr>
-        <p:txBody>
-          <a:bodyPr xmlns:a="http://schemas.openxmlformats.org/drawingml/2006/main" wrap="square" lIns="0" tIns="0" rIns="0" bIns="0" anchor="t">
-            <a:noAutofit/>
-          </a:bodyPr>
-          <a:lstStyle xmlns:a="http://schemas.openxmlformats.org/drawingml/2006/main"/>
+              <a:defRPr sz="1650" b="0">
+                <a:solidFill>
+                  <a:srgbClr val="6E6D68"/>
+                </a:solidFill>
+                <a:latin typeface="Inter"/>
+                <a:ea typeface="Inter"/>
+                <a:cs typeface="Inter"/>
+              </a:defRPr>
+            </a:pPr>
+            <a:r>
+              <a:rPr sz="1650" b="0">
+                <a:solidFill>
+                  <a:srgbClr val="6E6D68"/>
+                </a:solidFill>
+                <a:latin typeface="Inter"/>
+                <a:ea typeface="Inter"/>
+                <a:cs typeface="Inter"/>
+              </a:rPr>
+              <a:t>Ideen für spätere Versionen.</a:t>
+            </a:r>
+          </a:p>
           <a:p xmlns:a="http://schemas.openxmlformats.org/drawingml/2006/main">
             <a:pPr algn="l">
-              <a:defRPr sz="2100" b="0">
-                <a:solidFill>
-                  <a:srgbClr val="15171A"/>
-                </a:solidFill>
-                <a:latin typeface="Inter"/>
-                <a:ea typeface="Inter"/>
-                <a:cs typeface="Inter"/>
-              </a:defRPr>
-            </a:pPr>
-            <a:r>
-              <a:rPr sz="2100" b="0">
-                <a:solidFill>
-                  <a:srgbClr val="15171A"/>
-                </a:solidFill>
-                <a:latin typeface="Inter"/>
-                <a:ea typeface="Inter"/>
-                <a:cs typeface="Inter"/>
-              </a:rPr>
-              <a:t>Wird Spendly im Alltag wieder genutzt?</a:t>
-            </a:r>
-          </a:p>
-        </p:txBody>
-      </p:sp>
-      <p:sp>
-        <p:nvSpPr>
-          <p:cNvPr id="11" name="">
-            <a:extLst xmlns:a="http://schemas.openxmlformats.org/drawingml/2006/main">
-              <a:ext uri="{FF2B5EF4-FFF2-40B4-BE49-F238E27FC236}">
-                <a16:creationId xmlns:a16="http://schemas.microsoft.com/office/drawing/2014/main" id="{DDE93F8B-34E9-48D7-A1D2-97AE9E2B1B2A}"/>
-              </a:ext>
-            </a:extLst>
-          </p:cNvPr>
-          <p:cNvSpPr>
-            <a:spLocks xmlns:a="http://schemas.openxmlformats.org/drawingml/2006/main" noGrp="1"/>
-          </p:cNvSpPr>
-          <p:nvPr/>
-        </p:nvSpPr>
-        <p:spPr>
-          <a:xfrm xmlns:a="http://schemas.openxmlformats.org/drawingml/2006/main">
-            <a:off x="6448425" y="5562600"/>
-            <a:ext cx="5095875" cy="628650"/>
-          </a:xfrm>
-          <a:prstGeom xmlns:a="http://schemas.openxmlformats.org/drawingml/2006/main" prst="rect">
-            <a:avLst/>
-          </a:prstGeom>
-          <a:noFill xmlns:a="http://schemas.openxmlformats.org/drawingml/2006/main"/>
-          <a:ln xmlns:a="http://schemas.openxmlformats.org/drawingml/2006/main" w="0">
-            <a:noFill/>
-          </a:ln>
-        </p:spPr>
-        <p:txBody>
-          <a:bodyPr xmlns:a="http://schemas.openxmlformats.org/drawingml/2006/main" wrap="square" lIns="0" tIns="0" rIns="0" bIns="0" anchor="t">
-            <a:noAutofit/>
-          </a:bodyPr>
-          <a:lstStyle xmlns:a="http://schemas.openxmlformats.org/drawingml/2006/main"/>
-          <a:p xmlns:a="http://schemas.openxmlformats.org/drawingml/2006/main">
-            <a:pPr algn="l">
-              <a:defRPr sz="1575" b="0">
+              <a:defRPr sz="1650" b="0">
                 <a:solidFill>
                   <a:srgbClr val="6E6D68"/>
                 </a:solidFill>
@@ -7923,7 +7883,7 @@
               </a:defRPr>
             </a:pPr>
             <a:r>
-              <a:rPr sz="1575" b="0">
+              <a:rPr sz="1650" b="0">
                 <a:solidFill>
                   <a:srgbClr val="6E6D68"/>
                 </a:solidFill>
@@ -7931,30 +7891,7 @@
                 <a:ea typeface="Inter"/>
                 <a:cs typeface="Inter"/>
               </a:rPr>
-              <a:t>Vor einem Launch: echtes iPhone,</a:t>
-            </a:r>
-          </a:p>
-          <a:p xmlns:a="http://schemas.openxmlformats.org/drawingml/2006/main">
-            <a:pPr algn="l">
-              <a:defRPr sz="1575" b="0">
-                <a:solidFill>
-                  <a:srgbClr val="6E6D68"/>
-                </a:solidFill>
-                <a:latin typeface="Inter"/>
-                <a:ea typeface="Inter"/>
-                <a:cs typeface="Inter"/>
-              </a:defRPr>
-            </a:pPr>
-            <a:r>
-              <a:rPr sz="1575" b="0">
-                <a:solidFill>
-                  <a:srgbClr val="6E6D68"/>
-                </a:solidFill>
-                <a:latin typeface="Inter"/>
-                <a:ea typeface="Inter"/>
-                <a:cs typeface="Inter"/>
-              </a:rPr>
-              <a:t>Android und Screenreader vollständig prüfen.</a:t>
+              <a:t>Zuerst die Bedienung mit Nutzern prüfen.</a:t>
             </a:r>
           </a:p>
         </p:txBody>
@@ -7962,7 +7899,7 @@
     </p:spTree>
     <p:extLst>
       <p:ext uri="{BB962C8B-B14F-4D97-AF65-F5344CB8AC3E}">
-        <p14:creationId xmlns:p14="http://schemas.microsoft.com/office/powerpoint/2010/main" val="1403174672"/>
+        <p14:creationId xmlns:p14="http://schemas.microsoft.com/office/powerpoint/2010/main" val="155262311"/>
       </p:ext>
     </p:extLst>
   </p:cSld>

</xml_diff>